<commit_message>
Passe la présentation aux couleurs FDJ (bleu) et PMU (vert)
Co-Authored-By: Claude Opus 5.5 <noreply@anthropic.com>
Claude-Session: https://claude.ai/code/session_017NLVC91w22UbySgFrdcJQ1
</commit_message>
<xml_diff>
--- a/presentation/IA_LCB_points_de_vente.pptx
+++ b/presentation/IA_LCB_points_de_vente.pptx
@@ -111,27 +111,27 @@
   <p:extLst>
     <p:ext uri="{521415D9-36F7-43E2-AB2F-B90AF26B5E84}">
       <p14:sectionLst xmlns:p14="http://schemas.microsoft.com/office/powerpoint/2010/main">
-        <p14:section name="Introduction" id="{ca88c8df-0ad5-f0e7-157b-c4d139dcc497}">
+        <p14:section name="Introduction" id="{a82ce12b-0944-52b1-a49b-b09f20f420fb}">
           <p14:sldIdLst>
             <p14:sldId id="256"/>
           </p14:sldIdLst>
         </p14:section>
-        <p14:section name="Situation" id="{6cda24e0-788e-24fb-f0fc-b65228d96831}">
+        <p14:section name="Situation" id="{1ba1c318-c2e2-d7f3-428f-a6b095555067}">
           <p14:sldIdLst>
             <p14:sldId id="257"/>
           </p14:sldIdLst>
         </p14:section>
-        <p14:section name="Complication" id="{9962c2dd-8f89-5d2a-79af-c44000108fe3}">
+        <p14:section name="Complication" id="{6a515cca-7ff9-d2a3-2fe7-0af45bbc538a}">
           <p14:sldIdLst>
             <p14:sldId id="258"/>
           </p14:sldIdLst>
         </p14:section>
-        <p14:section name="Problematique" id="{45eef335-ebb3-8581-640d-198e7357f375}">
+        <p14:section name="Problematique" id="{395e02b9-1241-e5d4-de56-36a3ac79d940}">
           <p14:sldIdLst>
             <p14:sldId id="259"/>
           </p14:sldIdLst>
         </p14:section>
-        <p14:section name="Solution" id="{ff2263a9-53d0-87ff-4614-81989e21b4a0}">
+        <p14:section name="Solution" id="{ba6f7b79-5fe6-dfb3-dce5-63a7d5c1a0c7}">
           <p14:sldIdLst>
             <p14:sldId id="260"/>
           </p14:sldIdLst>
@@ -1682,7 +1682,7 @@
             <a:r>
               <a:rPr lang="en-US" sz="1800" i="1" dirty="0">
                 <a:solidFill>
-                  <a:srgbClr val="D4ECE8"/>
+                  <a:srgbClr val="DDF2E5"/>
                 </a:solidFill>
               </a:rPr>
               <a:t>Mieux détecter et traiter les risques dans les bars-tabacs</a:t>
@@ -1706,7 +1706,7 @@
             <a:avLst/>
           </a:prstGeom>
           <a:solidFill>
-            <a:srgbClr val="E59F2E"/>
+            <a:srgbClr val="00A651"/>
           </a:solidFill>
           <a:ln/>
         </p:spPr>
@@ -1762,7 +1762,7 @@
             <a:r>
               <a:rPr lang="en-US" sz="1400" dirty="0">
                 <a:solidFill>
-                  <a:srgbClr val="EEF2F4"/>
+                  <a:srgbClr val="EEF3F9"/>
                 </a:solidFill>
               </a:rPr>
               <a:t>Projet d’alternance</a:t>
@@ -1890,7 +1890,7 @@
             <a:avLst/>
           </a:prstGeom>
           <a:solidFill>
-            <a:srgbClr val="D4ECE8"/>
+            <a:srgbClr val="DDF2E5"/>
           </a:solidFill>
           <a:ln/>
         </p:spPr>
@@ -1946,7 +1946,7 @@
             <a:r>
               <a:rPr lang="en-US" sz="1600" b="1" dirty="0">
                 <a:solidFill>
-                  <a:srgbClr val="1C2B36"/>
+                  <a:srgbClr val="14213D"/>
                 </a:solidFill>
               </a:rPr>
               <a:t>FDJ et PMU</a:t>
@@ -1960,7 +1960,7 @@
             <a:r>
               <a:rPr lang="en-US" sz="1400" dirty="0">
                 <a:solidFill>
-                  <a:srgbClr val="5B6B78"/>
+                  <a:srgbClr val="5B6B7C"/>
                 </a:solidFill>
               </a:rPr>
               <a:t>La lutte contre le blanchiment d’argent est une obligation centrale pour les opérateurs de jeux.</a:t>
@@ -1984,7 +1984,7 @@
             <a:avLst/>
           </a:prstGeom>
           <a:solidFill>
-            <a:srgbClr val="D4ECE8"/>
+            <a:srgbClr val="DDF2E5"/>
           </a:solidFill>
           <a:ln/>
         </p:spPr>
@@ -2040,7 +2040,7 @@
             <a:r>
               <a:rPr lang="en-US" sz="1600" b="1" dirty="0">
                 <a:solidFill>
-                  <a:srgbClr val="1C2B36"/>
+                  <a:srgbClr val="14213D"/>
                 </a:solidFill>
               </a:rPr>
               <a:t>Les points de vente physiques</a:t>
@@ -2054,7 +2054,7 @@
             <a:r>
               <a:rPr lang="en-US" sz="1400" dirty="0">
                 <a:solidFill>
-                  <a:srgbClr val="5B6B78"/>
+                  <a:srgbClr val="5B6B7C"/>
                 </a:solidFill>
               </a:rPr>
               <a:t>Focus sur les bars-tabacs, au cœur des problématiques rencontrées en alternance.</a:t>
@@ -2078,7 +2078,7 @@
             <a:avLst/>
           </a:prstGeom>
           <a:solidFill>
-            <a:srgbClr val="D4ECE8"/>
+            <a:srgbClr val="DDF2E5"/>
           </a:solidFill>
           <a:ln/>
         </p:spPr>
@@ -2134,7 +2134,7 @@
             <a:r>
               <a:rPr lang="en-US" sz="1600" b="1" dirty="0">
                 <a:solidFill>
-                  <a:srgbClr val="1C2B36"/>
+                  <a:srgbClr val="14213D"/>
                 </a:solidFill>
               </a:rPr>
               <a:t>Notre objectif</a:t>
@@ -2148,7 +2148,7 @@
             <a:r>
               <a:rPr lang="en-US" sz="1400" dirty="0">
                 <a:solidFill>
-                  <a:srgbClr val="5B6B78"/>
+                  <a:srgbClr val="5B6B7C"/>
                 </a:solidFill>
               </a:rPr>
               <a:t>Améliorer la détection des situations suspectes et leur traitement par les équipes conformité.</a:t>
@@ -2174,7 +2174,7 @@
             </a:avLst>
           </a:prstGeom>
           <a:solidFill>
-            <a:srgbClr val="14212B"/>
+            <a:srgbClr val="0A2D6E"/>
           </a:solidFill>
           <a:ln/>
         </p:spPr>
@@ -2194,7 +2194,7 @@
             <a:avLst/>
           </a:prstGeom>
           <a:solidFill>
-            <a:srgbClr val="E59F2E"/>
+            <a:srgbClr val="00A651"/>
           </a:solidFill>
           <a:ln/>
         </p:spPr>
@@ -2250,7 +2250,7 @@
             <a:r>
               <a:rPr lang="en-US" sz="1600" b="1" dirty="0">
                 <a:solidFill>
-                  <a:srgbClr val="E59F2E"/>
+                  <a:srgbClr val="00A651"/>
                 </a:solidFill>
               </a:rPr>
               <a:t>Point de départ</a:t>
@@ -2437,7 +2437,7 @@
             <a:avLst/>
           </a:prstGeom>
           <a:solidFill>
-            <a:srgbClr val="E59F2E"/>
+            <a:srgbClr val="00A651"/>
           </a:solidFill>
           <a:ln/>
         </p:spPr>
@@ -2493,7 +2493,7 @@
             <a:r>
               <a:rPr lang="en-US" sz="1400" b="1" dirty="0">
                 <a:solidFill>
-                  <a:srgbClr val="1C2B36"/>
+                  <a:srgbClr val="14213D"/>
                 </a:solidFill>
               </a:rPr>
               <a:t>Suspicion</a:t>
@@ -2541,7 +2541,7 @@
             <a:avLst/>
           </a:prstGeom>
           <a:solidFill>
-            <a:srgbClr val="C2453B"/>
+            <a:srgbClr val="E30613"/>
           </a:solidFill>
           <a:ln/>
         </p:spPr>
@@ -2597,7 +2597,7 @@
             <a:r>
               <a:rPr lang="en-US" sz="1400" b="1" dirty="0">
                 <a:solidFill>
-                  <a:srgbClr val="1C2B36"/>
+                  <a:srgbClr val="14213D"/>
                 </a:solidFill>
               </a:rPr>
               <a:t>Arrêté préfectoral : fermeture</a:t>
@@ -2645,7 +2645,7 @@
             <a:avLst/>
           </a:prstGeom>
           <a:solidFill>
-            <a:srgbClr val="C2453B"/>
+            <a:srgbClr val="E30613"/>
           </a:solidFill>
           <a:ln/>
         </p:spPr>
@@ -2701,7 +2701,7 @@
             <a:r>
               <a:rPr lang="en-US" sz="1400" b="1" dirty="0">
                 <a:solidFill>
-                  <a:srgbClr val="1C2B36"/>
+                  <a:srgbClr val="14213D"/>
                 </a:solidFill>
               </a:rPr>
               <a:t>Contestation devant le juge</a:t>
@@ -2727,7 +2727,7 @@
             </a:avLst>
           </a:prstGeom>
           <a:solidFill>
-            <a:srgbClr val="EEF2F4"/>
+            <a:srgbClr val="EEF3F9"/>
           </a:solidFill>
           <a:ln/>
         </p:spPr>
@@ -2747,7 +2747,7 @@
             <a:avLst/>
           </a:prstGeom>
           <a:solidFill>
-            <a:srgbClr val="14212B"/>
+            <a:srgbClr val="0A2D6E"/>
           </a:solidFill>
           <a:ln/>
         </p:spPr>
@@ -2803,7 +2803,7 @@
             <a:r>
               <a:rPr lang="en-US" sz="1600" b="1" dirty="0">
                 <a:solidFill>
-                  <a:srgbClr val="1C2B36"/>
+                  <a:srgbClr val="14213D"/>
                 </a:solidFill>
               </a:rPr>
               <a:t>Économiques</a:t>
@@ -2839,7 +2839,7 @@
             <a:r>
               <a:rPr lang="en-US" sz="1300" dirty="0">
                 <a:solidFill>
-                  <a:srgbClr val="5B6B78"/>
+                  <a:srgbClr val="5B6B7C"/>
                 </a:solidFill>
               </a:rPr>
               <a:t>Activité interrompue, perte de chiffre d’affaires et de clientèle.</a:t>
@@ -2865,7 +2865,7 @@
             </a:avLst>
           </a:prstGeom>
           <a:solidFill>
-            <a:srgbClr val="EEF2F4"/>
+            <a:srgbClr val="EEF3F9"/>
           </a:solidFill>
           <a:ln/>
         </p:spPr>
@@ -2885,7 +2885,7 @@
             <a:avLst/>
           </a:prstGeom>
           <a:solidFill>
-            <a:srgbClr val="14212B"/>
+            <a:srgbClr val="0A2D6E"/>
           </a:solidFill>
           <a:ln/>
         </p:spPr>
@@ -2941,7 +2941,7 @@
             <a:r>
               <a:rPr lang="en-US" sz="1600" b="1" dirty="0">
                 <a:solidFill>
-                  <a:srgbClr val="1C2B36"/>
+                  <a:srgbClr val="14213D"/>
                 </a:solidFill>
               </a:rPr>
               <a:t>Réputationnelles</a:t>
@@ -2977,7 +2977,7 @@
             <a:r>
               <a:rPr lang="en-US" sz="1300" dirty="0">
                 <a:solidFill>
-                  <a:srgbClr val="5B6B78"/>
+                  <a:srgbClr val="5B6B7C"/>
                 </a:solidFill>
               </a:rPr>
               <a:t>Confiance des joueurs et des partenaires fragilisée.</a:t>
@@ -3003,7 +3003,7 @@
             </a:avLst>
           </a:prstGeom>
           <a:solidFill>
-            <a:srgbClr val="EEF2F4"/>
+            <a:srgbClr val="EEF3F9"/>
           </a:solidFill>
           <a:ln/>
         </p:spPr>
@@ -3023,7 +3023,7 @@
             <a:avLst/>
           </a:prstGeom>
           <a:solidFill>
-            <a:srgbClr val="14212B"/>
+            <a:srgbClr val="0A2D6E"/>
           </a:solidFill>
           <a:ln/>
         </p:spPr>
@@ -3079,7 +3079,7 @@
             <a:r>
               <a:rPr lang="en-US" sz="1600" b="1" dirty="0">
                 <a:solidFill>
-                  <a:srgbClr val="1C2B36"/>
+                  <a:srgbClr val="14213D"/>
                 </a:solidFill>
               </a:rPr>
               <a:t>Organisationnelles</a:t>
@@ -3115,7 +3115,7 @@
             <a:r>
               <a:rPr lang="en-US" sz="1300" dirty="0">
                 <a:solidFill>
-                  <a:srgbClr val="5B6B78"/>
+                  <a:srgbClr val="5B6B7C"/>
                 </a:solidFill>
               </a:rPr>
               <a:t>Contrôles, audits, justifications : équipes mobilisées.</a:t>
@@ -3141,7 +3141,7 @@
             </a:avLst>
           </a:prstGeom>
           <a:solidFill>
-            <a:srgbClr val="14212B"/>
+            <a:srgbClr val="0A2D6E"/>
           </a:solidFill>
           <a:ln/>
         </p:spPr>
@@ -3173,7 +3173,7 @@
             <a:r>
               <a:rPr lang="en-US" sz="1400" b="1" dirty="0">
                 <a:solidFill>
-                  <a:srgbClr val="E59F2E"/>
+                  <a:srgbClr val="00A651"/>
                 </a:solidFill>
               </a:rPr>
               <a:t>La difficulté : </a:t>
@@ -3368,7 +3368,7 @@
             <a:avLst/>
           </a:prstGeom>
           <a:solidFill>
-            <a:srgbClr val="2A8C82"/>
+            <a:srgbClr val="00A651"/>
           </a:solidFill>
           <a:ln/>
         </p:spPr>
@@ -3424,7 +3424,7 @@
             <a:r>
               <a:rPr lang="en-US" sz="1400" dirty="0">
                 <a:solidFill>
-                  <a:srgbClr val="EEF2F4"/>
+                  <a:srgbClr val="EEF3F9"/>
                 </a:solidFill>
               </a:rPr>
               <a:t>Points de vente de jeux,</a:t>
@@ -3438,7 +3438,7 @@
             <a:r>
               <a:rPr lang="en-US" sz="1400" dirty="0">
                 <a:solidFill>
-                  <a:srgbClr val="EEF2F4"/>
+                  <a:srgbClr val="EEF3F9"/>
                 </a:solidFill>
               </a:rPr>
               <a:t>notamment bars-tabacs</a:t>
@@ -3462,7 +3462,7 @@
             <a:avLst/>
           </a:prstGeom>
           <a:solidFill>
-            <a:srgbClr val="2A8C82"/>
+            <a:srgbClr val="00A651"/>
           </a:solidFill>
           <a:ln/>
         </p:spPr>
@@ -3518,7 +3518,7 @@
             <a:r>
               <a:rPr lang="en-US" sz="1400" dirty="0">
                 <a:solidFill>
-                  <a:srgbClr val="EEF2F4"/>
+                  <a:srgbClr val="EEF3F9"/>
                 </a:solidFill>
               </a:rPr>
               <a:t>Moins de</a:t>
@@ -3532,7 +3532,7 @@
             <a:r>
               <a:rPr lang="en-US" sz="1400" dirty="0">
                 <a:solidFill>
-                  <a:srgbClr val="EEF2F4"/>
+                  <a:srgbClr val="EEF3F9"/>
                 </a:solidFill>
               </a:rPr>
               <a:t>fausses alertes</a:t>
@@ -3556,7 +3556,7 @@
             <a:avLst/>
           </a:prstGeom>
           <a:solidFill>
-            <a:srgbClr val="2A8C82"/>
+            <a:srgbClr val="00A651"/>
           </a:solidFill>
           <a:ln/>
         </p:spPr>
@@ -3612,7 +3612,7 @@
             <a:r>
               <a:rPr lang="en-US" sz="1400" dirty="0">
                 <a:solidFill>
-                  <a:srgbClr val="EEF2F4"/>
+                  <a:srgbClr val="EEF3F9"/>
                 </a:solidFill>
               </a:rPr>
               <a:t>Moins de</a:t>
@@ -3626,7 +3626,7 @@
             <a:r>
               <a:rPr lang="en-US" sz="1400" dirty="0">
                 <a:solidFill>
-                  <a:srgbClr val="EEF2F4"/>
+                  <a:srgbClr val="EEF3F9"/>
                 </a:solidFill>
               </a:rPr>
               <a:t>temps d’analyse</a:t>
@@ -3756,7 +3756,7 @@
             </a:avLst>
           </a:prstGeom>
           <a:solidFill>
-            <a:srgbClr val="EEF2F4"/>
+            <a:srgbClr val="EEF3F9"/>
           </a:solidFill>
           <a:ln/>
         </p:spPr>
@@ -3788,7 +3788,7 @@
             <a:r>
               <a:rPr lang="en-US" sz="3600" b="1" dirty="0">
                 <a:solidFill>
-                  <a:srgbClr val="E59F2E"/>
+                  <a:srgbClr val="00A651"/>
                 </a:solidFill>
                 <a:latin typeface="Cambria" pitchFamily="34" charset="0"/>
                 <a:ea typeface="Cambria" pitchFamily="34" charset="-122"/>
@@ -3827,7 +3827,7 @@
             <a:r>
               <a:rPr lang="en-US" sz="1500" b="1" dirty="0">
                 <a:solidFill>
-                  <a:srgbClr val="1C2B36"/>
+                  <a:srgbClr val="14213D"/>
                 </a:solidFill>
               </a:rPr>
               <a:t>Quoi examiner en priorité ?</a:t>
@@ -3853,7 +3853,7 @@
             </a:avLst>
           </a:prstGeom>
           <a:solidFill>
-            <a:srgbClr val="EEF2F4"/>
+            <a:srgbClr val="EEF3F9"/>
           </a:solidFill>
           <a:ln/>
         </p:spPr>
@@ -3885,7 +3885,7 @@
             <a:r>
               <a:rPr lang="en-US" sz="3600" b="1" dirty="0">
                 <a:solidFill>
-                  <a:srgbClr val="E59F2E"/>
+                  <a:srgbClr val="00A651"/>
                 </a:solidFill>
                 <a:latin typeface="Cambria" pitchFamily="34" charset="0"/>
                 <a:ea typeface="Cambria" pitchFamily="34" charset="-122"/>
@@ -3924,7 +3924,7 @@
             <a:r>
               <a:rPr lang="en-US" sz="1500" b="1" dirty="0">
                 <a:solidFill>
-                  <a:srgbClr val="1C2B36"/>
+                  <a:srgbClr val="14213D"/>
                 </a:solidFill>
               </a:rPr>
               <a:t>Pourquoi est-ce inhabituel ?</a:t>
@@ -3950,7 +3950,7 @@
             </a:avLst>
           </a:prstGeom>
           <a:solidFill>
-            <a:srgbClr val="EEF2F4"/>
+            <a:srgbClr val="EEF3F9"/>
           </a:solidFill>
           <a:ln/>
         </p:spPr>
@@ -3982,7 +3982,7 @@
             <a:r>
               <a:rPr lang="en-US" sz="3600" b="1" dirty="0">
                 <a:solidFill>
-                  <a:srgbClr val="E59F2E"/>
+                  <a:srgbClr val="00A651"/>
                 </a:solidFill>
                 <a:latin typeface="Cambria" pitchFamily="34" charset="0"/>
                 <a:ea typeface="Cambria" pitchFamily="34" charset="-122"/>
@@ -4021,7 +4021,7 @@
             <a:r>
               <a:rPr lang="en-US" sz="1500" b="1" dirty="0">
                 <a:solidFill>
-                  <a:srgbClr val="1C2B36"/>
+                  <a:srgbClr val="14213D"/>
                 </a:solidFill>
               </a:rPr>
               <a:t>Quelles vérifications faire ?</a:t>
@@ -4047,7 +4047,7 @@
             </a:avLst>
           </a:prstGeom>
           <a:solidFill>
-            <a:srgbClr val="EEF2F4"/>
+            <a:srgbClr val="EEF3F9"/>
           </a:solidFill>
           <a:ln/>
           <a:effectLst>
@@ -4074,7 +4074,7 @@
             <a:avLst/>
           </a:prstGeom>
           <a:solidFill>
-            <a:srgbClr val="5B6B78"/>
+            <a:srgbClr val="5B6B7C"/>
           </a:solidFill>
           <a:ln/>
         </p:spPr>
@@ -4130,7 +4130,7 @@
             <a:r>
               <a:rPr lang="en-US" sz="1600" b="1" dirty="0">
                 <a:solidFill>
-                  <a:srgbClr val="1C2B36"/>
+                  <a:srgbClr val="14213D"/>
                 </a:solidFill>
               </a:rPr>
               <a:t>Données + terrain</a:t>
@@ -4166,7 +4166,7 @@
             <a:r>
               <a:rPr lang="en-US" sz="1300" dirty="0">
                 <a:solidFill>
-                  <a:srgbClr val="5B6B78"/>
+                  <a:srgbClr val="5B6B7C"/>
                 </a:solidFill>
               </a:rPr>
               <a:t>Données disponibles et remontées des points de vente</a:t>
@@ -4216,7 +4216,7 @@
             </a:avLst>
           </a:prstGeom>
           <a:solidFill>
-            <a:srgbClr val="14212B"/>
+            <a:srgbClr val="0A2D6E"/>
           </a:solidFill>
           <a:ln/>
           <a:effectLst>
@@ -4243,7 +4243,7 @@
             <a:avLst/>
           </a:prstGeom>
           <a:solidFill>
-            <a:srgbClr val="E59F2E"/>
+            <a:srgbClr val="00A651"/>
           </a:solidFill>
           <a:ln/>
         </p:spPr>
@@ -4335,7 +4335,7 @@
             <a:r>
               <a:rPr lang="en-US" sz="1300" dirty="0">
                 <a:solidFill>
-                  <a:srgbClr val="EEF2F4"/>
+                  <a:srgbClr val="EEF3F9"/>
                 </a:solidFill>
               </a:rPr>
               <a:t>Constitue le dossier, explique l’alerte, propose les vérifications</a:t>
@@ -4385,7 +4385,7 @@
             </a:avLst>
           </a:prstGeom>
           <a:solidFill>
-            <a:srgbClr val="D4ECE8"/>
+            <a:srgbClr val="DDF2E5"/>
           </a:solidFill>
           <a:ln/>
           <a:effectLst>
@@ -4412,7 +4412,7 @@
             <a:avLst/>
           </a:prstGeom>
           <a:solidFill>
-            <a:srgbClr val="2A8C82"/>
+            <a:srgbClr val="0057B8"/>
           </a:solidFill>
           <a:ln/>
         </p:spPr>
@@ -4468,7 +4468,7 @@
             <a:r>
               <a:rPr lang="en-US" sz="1600" b="1" dirty="0">
                 <a:solidFill>
-                  <a:srgbClr val="1C2B36"/>
+                  <a:srgbClr val="14213D"/>
                 </a:solidFill>
               </a:rPr>
               <a:t>Équipe conformité</a:t>
@@ -4504,7 +4504,7 @@
             <a:r>
               <a:rPr lang="en-US" sz="1300" dirty="0">
                 <a:solidFill>
-                  <a:srgbClr val="1C2B36"/>
+                  <a:srgbClr val="14213D"/>
                 </a:solidFill>
               </a:rPr>
               <a:t>Garde la décision sur les suites à donner</a:t>
@@ -4540,7 +4540,7 @@
             <a:r>
               <a:rPr lang="en-US" sz="1400" b="1" dirty="0">
                 <a:solidFill>
-                  <a:srgbClr val="2A8C82"/>
+                  <a:srgbClr val="0057B8"/>
                 </a:solidFill>
               </a:rPr>
               <a:t>Objectif : </a:t>
@@ -4551,7 +4551,7 @@
             <a:r>
               <a:rPr lang="en-US" sz="1400" dirty="0">
                 <a:solidFill>
-                  <a:srgbClr val="1C2B36"/>
+                  <a:srgbClr val="14213D"/>
                 </a:solidFill>
               </a:rPr>
               <a:t>mieux cibler les investigations, mieux les documenter et garder du temps pour les cas complexes.</a:t>
@@ -4614,47 +4614,47 @@
 </file>
 
 <file path=ppt/theme/theme1.xml><?xml version="1.0" encoding="utf-8"?>
-<a:theme xmlns:a="http://schemas.openxmlformats.org/drawingml/2006/main" name="Conformite LCB-FT">
+<a:theme xmlns:a="http://schemas.openxmlformats.org/drawingml/2006/main" name="FDJ PMU Conformite">
   <a:themeElements>
-    <a:clrScheme name="Conformite LCB-FT">
+    <a:clrScheme name="FDJ PMU Conformite">
       <a:dk1>
-        <a:srgbClr val="1C2B36"/>
+        <a:srgbClr val="14213D"/>
       </a:dk1>
       <a:lt1>
         <a:srgbClr val="FFFFFF"/>
       </a:lt1>
       <a:dk2>
-        <a:srgbClr val="14212B"/>
+        <a:srgbClr val="0A2D6E"/>
       </a:dk2>
       <a:lt2>
-        <a:srgbClr val="EEF2F4"/>
+        <a:srgbClr val="EEF3F9"/>
       </a:lt2>
       <a:accent1>
-        <a:srgbClr val="E59F2E"/>
+        <a:srgbClr val="00A651"/>
       </a:accent1>
       <a:accent2>
-        <a:srgbClr val="2A8C82"/>
+        <a:srgbClr val="0057B8"/>
       </a:accent2>
       <a:accent3>
-        <a:srgbClr val="C2453B"/>
+        <a:srgbClr val="E30613"/>
       </a:accent3>
       <a:accent4>
-        <a:srgbClr val="5B6B78"/>
+        <a:srgbClr val="5B6B7C"/>
       </a:accent4>
       <a:accent5>
-        <a:srgbClr val="F6E3C2"/>
+        <a:srgbClr val="DCE8F7"/>
       </a:accent5>
       <a:accent6>
-        <a:srgbClr val="D4ECE8"/>
+        <a:srgbClr val="DDF2E5"/>
       </a:accent6>
       <a:hlink>
-        <a:srgbClr val="2A8C82"/>
+        <a:srgbClr val="0057B8"/>
       </a:hlink>
       <a:folHlink>
-        <a:srgbClr val="5B6B78"/>
+        <a:srgbClr val="5B6B7C"/>
       </a:folHlink>
     </a:clrScheme>
-    <a:fontScheme name="Conformite LCB-FT">
+    <a:fontScheme name="FDJ PMU Conformite">
       <a:majorFont>
         <a:latin typeface="Cambria"/>
         <a:ea typeface=""/>

</xml_diff>

<commit_message>
Retire la mention « Projet d'alternance » de la slide de titre
Co-Authored-By: Claude Opus 5.5 <noreply@anthropic.com>
Claude-Session: https://claude.ai/code/session_017NLVC91w22UbySgFrdcJQ1
</commit_message>
<xml_diff>
--- a/presentation/IA_LCB_points_de_vente.pptx
+++ b/presentation/IA_LCB_points_de_vente.pptx
@@ -111,27 +111,27 @@
   <p:extLst>
     <p:ext uri="{521415D9-36F7-43E2-AB2F-B90AF26B5E84}">
       <p14:sectionLst xmlns:p14="http://schemas.microsoft.com/office/powerpoint/2010/main">
-        <p14:section name="Introduction" id="{a82ce12b-0944-52b1-a49b-b09f20f420fb}">
+        <p14:section name="Introduction" id="{aca607ba-1a21-bf2a-402d-718fca1d9cca}">
           <p14:sldIdLst>
             <p14:sldId id="256"/>
           </p14:sldIdLst>
         </p14:section>
-        <p14:section name="Situation" id="{1ba1c318-c2e2-d7f3-428f-a6b095555067}">
+        <p14:section name="Situation" id="{30154e43-8708-c7e3-ae90-d0fdfa457a42}">
           <p14:sldIdLst>
             <p14:sldId id="257"/>
           </p14:sldIdLst>
         </p14:section>
-        <p14:section name="Complication" id="{6a515cca-7ff9-d2a3-2fe7-0af45bbc538a}">
+        <p14:section name="Complication" id="{1da824fd-5504-b690-dce5-f52c333f1aa7}">
           <p14:sldIdLst>
             <p14:sldId id="258"/>
           </p14:sldIdLst>
         </p14:section>
-        <p14:section name="Problematique" id="{395e02b9-1241-e5d4-de56-36a3ac79d940}">
+        <p14:section name="Problematique" id="{b96f6d2e-95d5-f635-a5ff-c69cc0a3c55e}">
           <p14:sldIdLst>
             <p14:sldId id="259"/>
           </p14:sldIdLst>
         </p14:section>
-        <p14:section name="Solution" id="{ba6f7b79-5fe6-dfb3-dce5-63a7d5c1a0c7}">
+        <p14:section name="Solution" id="{518ff368-eda4-23ee-69f3-1546d317a736}">
           <p14:sldIdLst>
             <p14:sldId id="260"/>
           </p14:sldIdLst>
@@ -1735,42 +1735,6 @@
           </a:prstGeom>
         </p:spPr>
       </p:pic>
-      <p:sp>
-        <p:nvSpPr>
-          <p:cNvPr id="7" name="Text 4"/>
-          <p:cNvSpPr txBox="1"/>
-          <p:nvPr/>
-        </p:nvSpPr>
-        <p:spPr>
-          <a:xfrm>
-            <a:off x="1371600" y="3931920"/>
-            <a:ext cx="3657600" cy="457200"/>
-          </a:xfrm>
-          <a:prstGeom prst="rect">
-            <a:avLst/>
-          </a:prstGeom>
-          <a:noFill/>
-          <a:ln/>
-        </p:spPr>
-        <p:txBody>
-          <a:bodyPr wrap="square" lIns="0" tIns="0" rIns="0" bIns="0" rtlCol="0" anchor="ctr"/>
-          <a:lstStyle/>
-          <a:p>
-            <a:pPr indent="0" marL="0">
-              <a:buNone/>
-            </a:pPr>
-            <a:r>
-              <a:rPr lang="en-US" sz="1400" dirty="0">
-                <a:solidFill>
-                  <a:srgbClr val="EEF3F9"/>
-                </a:solidFill>
-              </a:rPr>
-              <a:t>Projet d’alternance</a:t>
-            </a:r>
-            <a:endParaRPr lang="en-US" sz="1400" dirty="0"/>
-          </a:p>
-        </p:txBody>
-      </p:sp>
     </p:spTree>
   </p:cSld>
   <p:clrMapOvr>

</xml_diff>